<commit_message>
Voeg eenmalige kick-off fee van 995 euro toe aan pilotvoorstel
De tijdlijn op slide 7 noemt de fee bij de kick-off en de
totaalkaart telt op naar 5.495 euro excl. btw (995 kick-off
plus drie werkperiodes van 1.500). PDF, previews en PPTX
opnieuw gebouwd vanuit de contentlaag.

Co-Authored-By: Claude Fable 5 <noreply@anthropic.com>
Claude-Session: https://claude.ai/code/session_0141FN3f3hHkYQHTyvTJJGrw
</commit_message>
<xml_diff>
--- a/output/LINK. kennismaking Techmetric3d.pptx
+++ b/output/LINK. kennismaking Techmetric3d.pptx
@@ -8276,7 +8276,7 @@
                 <a:ea typeface="Arial" pitchFamily="34" charset="-122"/>
                 <a:cs typeface="Arial" pitchFamily="34" charset="-120"/>
               </a:rPr>
-              <a:t>Totale investering € 4.500 excl. btw, dat is € 375 per gekwalificeerde afspraak</a:t>
+              <a:t>Totale investering € 5.495 excl. btw: eenmalige kick-off fee van € 995 plus drie werkperiodes van € 1.500</a:t>
             </a:r>
             <a:endParaRPr lang="en-US" sz="900" dirty="0"/>
           </a:p>
@@ -8399,7 +8399,7 @@
                 <a:ea typeface="Arial" pitchFamily="34" charset="-122"/>
                 <a:cs typeface="Arial" pitchFamily="34" charset="-120"/>
               </a:rPr>
-              <a:t>2 WEKEN</a:t>
+              <a:t>2 WEKEN · EENMALIG € 995</a:t>
             </a:r>
             <a:endParaRPr lang="en-US" sz="750" dirty="0"/>
           </a:p>

</xml_diff>